<commit_message>
Slides: badged PPTX of sd-04-047
</commit_message>
<xml_diff>
--- a/system-design-101/vi/lessons/sd-04-047/slides/sd-04-047.pptx
+++ b/system-design-101/vi/lessons/sd-04-047/slides/sd-04-047.pptx
@@ -2050,7 +2050,7 @@
               <a:t>Nhanh</a:t>
             </a:r>
             <a:r>
-              <a:rPr lang="en-US" sz="2250" dirty="0" spc="1" kern="0">
+              <a:rPr lang="en-US" sz="2250" dirty="0" spc="2" kern="0">
                 <a:solidFill>
                   <a:srgbClr val="9AA0B5"/>
                 </a:solidFill>
@@ -2058,7 +2058,62 @@
                 <a:ea typeface="Be Vietnam Pro" pitchFamily="34" charset="-122"/>
                 <a:cs typeface="Be Vietnam Pro" pitchFamily="34" charset="-120"/>
               </a:rPr>
-              <a:t> hơn</a:t>
+              <a:t> hơn:</a:t>
+            </a:r>
+            <a:r>
+              <a:rPr lang="en-US" sz="2250" dirty="0" spc="4" kern="0">
+                <a:solidFill>
+                  <a:srgbClr val="9AA0B5"/>
+                </a:solidFill>
+                <a:latin typeface="Be Vietnam Pro" pitchFamily="34" charset="0"/>
+                <a:ea typeface="Be Vietnam Pro" pitchFamily="34" charset="-122"/>
+                <a:cs typeface="Be Vietnam Pro" pitchFamily="34" charset="-120"/>
+              </a:rPr>
+              <a:t> dữ</a:t>
+            </a:r>
+            <a:r>
+              <a:rPr lang="en-US" sz="2250" dirty="0" spc="-2" kern="0">
+                <a:solidFill>
+                  <a:srgbClr val="9AA0B5"/>
+                </a:solidFill>
+                <a:latin typeface="Be Vietnam Pro" pitchFamily="34" charset="0"/>
+                <a:ea typeface="Be Vietnam Pro" pitchFamily="34" charset="-122"/>
+                <a:cs typeface="Be Vietnam Pro" pitchFamily="34" charset="-120"/>
+              </a:rPr>
+              <a:t> liệu</a:t>
+            </a:r>
+            <a:r>
+              <a:rPr lang="en-US" sz="2250" dirty="0" spc="5" kern="0">
+                <a:solidFill>
+                  <a:srgbClr val="9AA0B5"/>
+                </a:solidFill>
+                <a:latin typeface="Be Vietnam Pro" pitchFamily="34" charset="0"/>
+                <a:ea typeface="Be Vietnam Pro" pitchFamily="34" charset="-122"/>
+                <a:cs typeface="Be Vietnam Pro" pitchFamily="34" charset="-120"/>
+              </a:rPr>
+              <a:t> cũ</a:t>
+            </a:r>
+            <a:r>
+              <a:rPr lang="en-US" sz="2250" dirty="0" spc="-1" kern="0">
+                <a:solidFill>
+                  <a:srgbClr val="9AA0B5"/>
+                </a:solidFill>
+                <a:latin typeface="Be Vietnam Pro" pitchFamily="34" charset="0"/>
+                <a:ea typeface="Be Vietnam Pro" pitchFamily="34" charset="-122"/>
+                <a:cs typeface="Be Vietnam Pro" pitchFamily="34" charset="-120"/>
+              </a:rPr>
+              <a:t> hơn,</a:t>
+            </a:r>
+            <a:r>
+              <a:rPr lang="en-US" sz="2250" dirty="0" spc="-3" kern="0">
+                <a:solidFill>
+                  <a:srgbClr val="9AA0B5"/>
+                </a:solidFill>
+                <a:latin typeface="Be Vietnam Pro" pitchFamily="34" charset="0"/>
+                <a:ea typeface="Be Vietnam Pro" pitchFamily="34" charset="-122"/>
+                <a:cs typeface="Be Vietnam Pro" pitchFamily="34" charset="-120"/>
+              </a:rPr>
+              <a:t> hoặc</a:t>
             </a:r>
             <a:r>
               <a:rPr lang="en-US" sz="2250" dirty="0" spc="0" kern="0">
@@ -2069,10 +2124,10 @@
                 <a:ea typeface="Be Vietnam Pro" pitchFamily="34" charset="-122"/>
                 <a:cs typeface="Be Vietnam Pro" pitchFamily="34" charset="-120"/>
               </a:rPr>
-              <a:t> thì</a:t>
-            </a:r>
-            <a:r>
-              <a:rPr lang="en-US" sz="2250" dirty="0" spc="-24" kern="0">
+              <a:t> thêm</a:t>
+            </a:r>
+            <a:r>
+              <a:rPr lang="en-US" sz="2250" dirty="0" spc="-12" kern="0">
                 <a:solidFill>
                   <a:srgbClr val="9AA0B5"/>
                 </a:solidFill>
@@ -2080,10 +2135,10 @@
                 <a:ea typeface="Be Vietnam Pro" pitchFamily="34" charset="-122"/>
                 <a:cs typeface="Be Vietnam Pro" pitchFamily="34" charset="-120"/>
               </a:rPr>
-              <a:t> trả</a:t>
-            </a:r>
-            <a:r>
-              <a:rPr lang="en-US" sz="2250" dirty="0" spc="-2" kern="0">
+              <a:t> vận</a:t>
+            </a:r>
+            <a:r>
+              <a:rPr lang="en-US" sz="2250" dirty="0" spc="0" kern="0">
                 <a:solidFill>
                   <a:srgbClr val="9AA0B5"/>
                 </a:solidFill>
@@ -2091,51 +2146,7 @@
                 <a:ea typeface="Be Vietnam Pro" pitchFamily="34" charset="-122"/>
                 <a:cs typeface="Be Vietnam Pro" pitchFamily="34" charset="-120"/>
               </a:rPr>
-              <a:t> bằng</a:t>
-            </a:r>
-            <a:r>
-              <a:rPr lang="en-US" sz="2250" dirty="0" spc="5" kern="0">
-                <a:solidFill>
-                  <a:srgbClr val="9AA0B5"/>
-                </a:solidFill>
-                <a:latin typeface="Be Vietnam Pro" pitchFamily="34" charset="0"/>
-                <a:ea typeface="Be Vietnam Pro" pitchFamily="34" charset="-122"/>
-                <a:cs typeface="Be Vietnam Pro" pitchFamily="34" charset="-120"/>
-              </a:rPr>
-              <a:t> dữ</a:t>
-            </a:r>
-            <a:r>
-              <a:rPr lang="en-US" sz="2250" dirty="0" spc="-2" kern="0">
-                <a:solidFill>
-                  <a:srgbClr val="9AA0B5"/>
-                </a:solidFill>
-                <a:latin typeface="Be Vietnam Pro" pitchFamily="34" charset="0"/>
-                <a:ea typeface="Be Vietnam Pro" pitchFamily="34" charset="-122"/>
-                <a:cs typeface="Be Vietnam Pro" pitchFamily="34" charset="-120"/>
-              </a:rPr>
-              <a:t> liệu</a:t>
-            </a:r>
-            <a:r>
-              <a:rPr lang="en-US" sz="2250" dirty="0" spc="5" kern="0">
-                <a:solidFill>
-                  <a:srgbClr val="9AA0B5"/>
-                </a:solidFill>
-                <a:latin typeface="Be Vietnam Pro" pitchFamily="34" charset="0"/>
-                <a:ea typeface="Be Vietnam Pro" pitchFamily="34" charset="-122"/>
-                <a:cs typeface="Be Vietnam Pro" pitchFamily="34" charset="-120"/>
-              </a:rPr>
-              <a:t> cũ</a:t>
-            </a:r>
-            <a:r>
-              <a:rPr lang="en-US" sz="2250" dirty="0" spc="0" kern="0">
-                <a:solidFill>
-                  <a:srgbClr val="9AA0B5"/>
-                </a:solidFill>
-                <a:latin typeface="Be Vietnam Pro" pitchFamily="34" charset="0"/>
-                <a:ea typeface="Be Vietnam Pro" pitchFamily="34" charset="-122"/>
-                <a:cs typeface="Be Vietnam Pro" pitchFamily="34" charset="-120"/>
-              </a:rPr>
-              <a:t> hơn</a:t>
+              <a:t> hành</a:t>
             </a:r>
             <a:endParaRPr lang="en-US" sz="2250" dirty="0"/>
           </a:p>

</xml_diff>